<commit_message>
3.06 says 'Lessons 6–7', like the other two-lesson periods
The 3.06 spec gave lesson_no="6–7", so every 3.06 document read 'Lesson 6–7' (title slide
'LESSON 6–7') where 4.02 and 4.07 read 'Lessons 2–3' and 'Lessons 7–8'. The spec now uses
label="Lessons 6–7", the Unit 4 form. Unit 3 rebuilt whole (build_all u3 --install): every
check 0 findings. Only the 3.06 documents changed in content — 27 files, each differing from
the last commit by the label wording alone (135 occurrences), verified text-for-text; the other
258 rebuilt files were timestamp-only and are left as they were.

Co-Authored-By: Claude Opus 5 <noreply@anthropic.com>
Claude-Session: https://claude.ai/code/session_015xYWeLUsuszQH6z7ADE9tj
</commit_message>
<xml_diff>
--- a/a7/build/out/u3/A7 3.06  Slides.pptx
+++ b/a7/build/out/u3/A7 3.06  Slides.pptx
@@ -3152,7 +3152,7 @@
                 </a:solidFill>
                 <a:latin typeface="Century Schoolbook"/>
               </a:rPr>
-              <a:t>GRADE 7 ACCELERATED  ·  UNIT 3  ·  LESSON 6–7</a:t>
+              <a:t>GRADE 7 ACCELERATED  ·  UNIT 3  ·  LESSONS 6–7</a:t>
             </a:r>
           </a:p>
         </p:txBody>
@@ -3513,7 +3513,7 @@
                 </a:solidFill>
                 <a:latin typeface="Century Schoolbook"/>
               </a:rPr>
-              <a:t>Grade 7 Accelerated · Unit 3 · Lesson 6–7 — Evaluating and Equivalent Expressions</a:t>
+              <a:t>Grade 7 Accelerated · Unit 3 · Lessons 6–7 — Evaluating and Equivalent Expressions</a:t>
             </a:r>
           </a:p>
         </p:txBody>
@@ -3776,7 +3776,7 @@
                 </a:solidFill>
                 <a:latin typeface="Century Schoolbook"/>
               </a:rPr>
-              <a:t>Grade 7 Accelerated · Unit 3 · Lesson 6–7 — Evaluating and Equivalent Expressions</a:t>
+              <a:t>Grade 7 Accelerated · Unit 3 · Lessons 6–7 — Evaluating and Equivalent Expressions</a:t>
             </a:r>
           </a:p>
         </p:txBody>
@@ -4063,7 +4063,7 @@
                 </a:solidFill>
                 <a:latin typeface="Century Schoolbook"/>
               </a:rPr>
-              <a:t>Grade 7 Accelerated · Unit 3 · Lesson 6–7 — Evaluating and Equivalent Expressions</a:t>
+              <a:t>Grade 7 Accelerated · Unit 3 · Lessons 6–7 — Evaluating and Equivalent Expressions</a:t>
             </a:r>
           </a:p>
         </p:txBody>
@@ -4462,7 +4462,7 @@
                 </a:solidFill>
                 <a:latin typeface="Century Schoolbook"/>
               </a:rPr>
-              <a:t>Grade 7 Accelerated · Unit 3 · Lesson 6–7 — Evaluating and Equivalent Expressions</a:t>
+              <a:t>Grade 7 Accelerated · Unit 3 · Lessons 6–7 — Evaluating and Equivalent Expressions</a:t>
             </a:r>
           </a:p>
         </p:txBody>
@@ -4913,7 +4913,7 @@
                 </a:solidFill>
                 <a:latin typeface="Century Schoolbook"/>
               </a:rPr>
-              <a:t>Grade 7 Accelerated · Unit 3 · Lesson 6–7 — Evaluating and Equivalent Expressions</a:t>
+              <a:t>Grade 7 Accelerated · Unit 3 · Lessons 6–7 — Evaluating and Equivalent Expressions</a:t>
             </a:r>
           </a:p>
         </p:txBody>
@@ -5424,7 +5424,7 @@
                 </a:solidFill>
                 <a:latin typeface="Century Schoolbook"/>
               </a:rPr>
-              <a:t>Grade 7 Accelerated · Unit 3 · Lesson 6–7 — Evaluating and Equivalent Expressions</a:t>
+              <a:t>Grade 7 Accelerated · Unit 3 · Lessons 6–7 — Evaluating and Equivalent Expressions</a:t>
             </a:r>
           </a:p>
         </p:txBody>
@@ -5840,7 +5840,7 @@
                 </a:solidFill>
                 <a:latin typeface="Century Schoolbook"/>
               </a:rPr>
-              <a:t>Grade 7 Accelerated · Unit 3 · Lesson 6–7 — Evaluating and Equivalent Expressions</a:t>
+              <a:t>Grade 7 Accelerated · Unit 3 · Lessons 6–7 — Evaluating and Equivalent Expressions</a:t>
             </a:r>
           </a:p>
         </p:txBody>
@@ -6389,7 +6389,7 @@
                 </a:solidFill>
                 <a:latin typeface="Century Schoolbook"/>
               </a:rPr>
-              <a:t>Grade 7 Accelerated · Unit 3 · Lesson 6–7 — Evaluating and Equivalent Expressions</a:t>
+              <a:t>Grade 7 Accelerated · Unit 3 · Lessons 6–7 — Evaluating and Equivalent Expressions</a:t>
             </a:r>
           </a:p>
         </p:txBody>
@@ -6746,7 +6746,7 @@
                 </a:solidFill>
                 <a:latin typeface="Century Schoolbook"/>
               </a:rPr>
-              <a:t>Grade 7 Accelerated · Unit 3 · Lesson 6–7 — Evaluating and Equivalent Expressions</a:t>
+              <a:t>Grade 7 Accelerated · Unit 3 · Lessons 6–7 — Evaluating and Equivalent Expressions</a:t>
             </a:r>
           </a:p>
         </p:txBody>
@@ -7148,7 +7148,7 @@
                 </a:solidFill>
                 <a:latin typeface="Century Schoolbook"/>
               </a:rPr>
-              <a:t>Grade 7 Accelerated · Unit 3 · Lesson 6–7 — Evaluating and Equivalent Expressions</a:t>
+              <a:t>Grade 7 Accelerated · Unit 3 · Lessons 6–7 — Evaluating and Equivalent Expressions</a:t>
             </a:r>
           </a:p>
         </p:txBody>
@@ -7505,7 +7505,7 @@
                 </a:solidFill>
                 <a:latin typeface="Century Schoolbook"/>
               </a:rPr>
-              <a:t>Grade 7 Accelerated · Unit 3 · Lesson 6–7 — Evaluating and Equivalent Expressions</a:t>
+              <a:t>Grade 7 Accelerated · Unit 3 · Lessons 6–7 — Evaluating and Equivalent Expressions</a:t>
             </a:r>
           </a:p>
         </p:txBody>
@@ -7895,7 +7895,7 @@
                 </a:solidFill>
                 <a:latin typeface="Century Schoolbook"/>
               </a:rPr>
-              <a:t>Grade 7 Accelerated · Unit 3 · Lesson 6–7 — Evaluating and Equivalent Expressions</a:t>
+              <a:t>Grade 7 Accelerated · Unit 3 · Lessons 6–7 — Evaluating and Equivalent Expressions</a:t>
             </a:r>
           </a:p>
         </p:txBody>
@@ -8370,7 +8370,7 @@
                 </a:solidFill>
                 <a:latin typeface="Century Schoolbook"/>
               </a:rPr>
-              <a:t>Grade 7 Accelerated · Unit 3 · Lesson 6–7 — Evaluating and Equivalent Expressions</a:t>
+              <a:t>Grade 7 Accelerated · Unit 3 · Lessons 6–7 — Evaluating and Equivalent Expressions</a:t>
             </a:r>
           </a:p>
         </p:txBody>
@@ -8727,7 +8727,7 @@
                 </a:solidFill>
                 <a:latin typeface="Century Schoolbook"/>
               </a:rPr>
-              <a:t>Grade 7 Accelerated · Unit 3 · Lesson 6–7 — Evaluating and Equivalent Expressions</a:t>
+              <a:t>Grade 7 Accelerated · Unit 3 · Lessons 6–7 — Evaluating and Equivalent Expressions</a:t>
             </a:r>
           </a:p>
         </p:txBody>
@@ -9171,7 +9171,7 @@
                 </a:solidFill>
                 <a:latin typeface="Century Schoolbook"/>
               </a:rPr>
-              <a:t>Grade 7 Accelerated · Unit 3 · Lesson 6–7 — Evaluating and Equivalent Expressions</a:t>
+              <a:t>Grade 7 Accelerated · Unit 3 · Lessons 6–7 — Evaluating and Equivalent Expressions</a:t>
             </a:r>
           </a:p>
         </p:txBody>
@@ -9727,7 +9727,7 @@
                 </a:solidFill>
                 <a:latin typeface="Century Schoolbook"/>
               </a:rPr>
-              <a:t>Grade 7 Accelerated · Unit 3 · Lesson 6–7 — Evaluating and Equivalent Expressions</a:t>
+              <a:t>Grade 7 Accelerated · Unit 3 · Lessons 6–7 — Evaluating and Equivalent Expressions</a:t>
             </a:r>
           </a:p>
         </p:txBody>
@@ -10352,7 +10352,7 @@
                 </a:solidFill>
                 <a:latin typeface="Century Schoolbook"/>
               </a:rPr>
-              <a:t>Grade 7 Accelerated · Unit 3 · Lesson 6–7 — Evaluating and Equivalent Expressions</a:t>
+              <a:t>Grade 7 Accelerated · Unit 3 · Lessons 6–7 — Evaluating and Equivalent Expressions</a:t>
             </a:r>
           </a:p>
         </p:txBody>
@@ -10921,7 +10921,7 @@
                 </a:solidFill>
                 <a:latin typeface="Century Schoolbook"/>
               </a:rPr>
-              <a:t>Grade 7 Accelerated · Unit 3 · Lesson 6–7 — Evaluating and Equivalent Expressions</a:t>
+              <a:t>Grade 7 Accelerated · Unit 3 · Lessons 6–7 — Evaluating and Equivalent Expressions</a:t>
             </a:r>
           </a:p>
         </p:txBody>
@@ -11499,7 +11499,7 @@
                 </a:solidFill>
                 <a:latin typeface="Century Schoolbook"/>
               </a:rPr>
-              <a:t>Grade 7 Accelerated · Unit 3 · Lesson 6–7 — Evaluating and Equivalent Expressions</a:t>
+              <a:t>Grade 7 Accelerated · Unit 3 · Lessons 6–7 — Evaluating and Equivalent Expressions</a:t>
             </a:r>
           </a:p>
         </p:txBody>
@@ -12068,7 +12068,7 @@
                 </a:solidFill>
                 <a:latin typeface="Century Schoolbook"/>
               </a:rPr>
-              <a:t>Grade 7 Accelerated · Unit 3 · Lesson 6–7 — Evaluating and Equivalent Expressions</a:t>
+              <a:t>Grade 7 Accelerated · Unit 3 · Lessons 6–7 — Evaluating and Equivalent Expressions</a:t>
             </a:r>
           </a:p>
         </p:txBody>
@@ -12646,7 +12646,7 @@
                 </a:solidFill>
                 <a:latin typeface="Century Schoolbook"/>
               </a:rPr>
-              <a:t>Grade 7 Accelerated · Unit 3 · Lesson 6–7 — Evaluating and Equivalent Expressions</a:t>
+              <a:t>Grade 7 Accelerated · Unit 3 · Lessons 6–7 — Evaluating and Equivalent Expressions</a:t>
             </a:r>
           </a:p>
         </p:txBody>
@@ -13003,7 +13003,7 @@
                 </a:solidFill>
                 <a:latin typeface="Century Schoolbook"/>
               </a:rPr>
-              <a:t>Grade 7 Accelerated · Unit 3 · Lesson 6–7 — Evaluating and Equivalent Expressions</a:t>
+              <a:t>Grade 7 Accelerated · Unit 3 · Lessons 6–7 — Evaluating and Equivalent Expressions</a:t>
             </a:r>
           </a:p>
         </p:txBody>
@@ -13447,7 +13447,7 @@
                 </a:solidFill>
                 <a:latin typeface="Century Schoolbook"/>
               </a:rPr>
-              <a:t>Grade 7 Accelerated · Unit 3 · Lesson 6–7 — Evaluating and Equivalent Expressions</a:t>
+              <a:t>Grade 7 Accelerated · Unit 3 · Lessons 6–7 — Evaluating and Equivalent Expressions</a:t>
             </a:r>
           </a:p>
         </p:txBody>
@@ -14158,7 +14158,7 @@
                 </a:solidFill>
                 <a:latin typeface="Century Schoolbook"/>
               </a:rPr>
-              <a:t>Grade 7 Accelerated · Unit 3 · Lesson 6–7 — Evaluating and Equivalent Expressions</a:t>
+              <a:t>Grade 7 Accelerated · Unit 3 · Lessons 6–7 — Evaluating and Equivalent Expressions</a:t>
             </a:r>
           </a:p>
         </p:txBody>
@@ -14515,7 +14515,7 @@
                 </a:solidFill>
                 <a:latin typeface="Century Schoolbook"/>
               </a:rPr>
-              <a:t>Grade 7 Accelerated · Unit 3 · Lesson 6–7 — Evaluating and Equivalent Expressions</a:t>
+              <a:t>Grade 7 Accelerated · Unit 3 · Lessons 6–7 — Evaluating and Equivalent Expressions</a:t>
             </a:r>
           </a:p>
         </p:txBody>
@@ -14941,7 +14941,7 @@
                 </a:solidFill>
                 <a:latin typeface="Century Schoolbook"/>
               </a:rPr>
-              <a:t>Grade 7 Accelerated · Unit 3 · Lesson 6–7 — Evaluating and Equivalent Expressions</a:t>
+              <a:t>Grade 7 Accelerated · Unit 3 · Lessons 6–7 — Evaluating and Equivalent Expressions</a:t>
             </a:r>
           </a:p>
         </p:txBody>
@@ -15521,7 +15521,7 @@
                 </a:solidFill>
                 <a:latin typeface="Century Schoolbook"/>
               </a:rPr>
-              <a:t>Grade 7 Accelerated · Unit 3 · Lesson 6–7 — Evaluating and Equivalent Expressions</a:t>
+              <a:t>Grade 7 Accelerated · Unit 3 · Lessons 6–7 — Evaluating and Equivalent Expressions</a:t>
             </a:r>
           </a:p>
         </p:txBody>
@@ -16155,7 +16155,7 @@
                 </a:solidFill>
                 <a:latin typeface="Century Schoolbook"/>
               </a:rPr>
-              <a:t>Grade 7 Accelerated · Unit 3 · Lesson 6–7 — Evaluating and Equivalent Expressions</a:t>
+              <a:t>Grade 7 Accelerated · Unit 3 · Lessons 6–7 — Evaluating and Equivalent Expressions</a:t>
             </a:r>
           </a:p>
         </p:txBody>
@@ -16628,7 +16628,7 @@
                 </a:solidFill>
                 <a:latin typeface="Century Schoolbook"/>
               </a:rPr>
-              <a:t>Grade 7 Accelerated · Unit 3 · Lesson 6–7 — Evaluating and Equivalent Expressions</a:t>
+              <a:t>Grade 7 Accelerated · Unit 3 · Lessons 6–7 — Evaluating and Equivalent Expressions</a:t>
             </a:r>
           </a:p>
         </p:txBody>
@@ -17171,7 +17171,7 @@
                 </a:solidFill>
                 <a:latin typeface="Century Schoolbook"/>
               </a:rPr>
-              <a:t>Grade 7 Accelerated · Unit 3 · Lesson 6–7 — Evaluating and Equivalent Expressions</a:t>
+              <a:t>Grade 7 Accelerated · Unit 3 · Lessons 6–7 — Evaluating and Equivalent Expressions</a:t>
             </a:r>
           </a:p>
         </p:txBody>
@@ -17657,7 +17657,7 @@
                 </a:solidFill>
                 <a:latin typeface="Century Schoolbook"/>
               </a:rPr>
-              <a:t>Grade 7 Accelerated · Unit 3 · Lesson 6–7 — Evaluating and Equivalent Expressions</a:t>
+              <a:t>Grade 7 Accelerated · Unit 3 · Lessons 6–7 — Evaluating and Equivalent Expressions</a:t>
             </a:r>
           </a:p>
         </p:txBody>
@@ -18180,7 +18180,7 @@
                 </a:solidFill>
                 <a:latin typeface="Century Schoolbook"/>
               </a:rPr>
-              <a:t>Grade 7 Accelerated · Unit 3 · Lesson 6–7 — Evaluating and Equivalent Expressions</a:t>
+              <a:t>Grade 7 Accelerated · Unit 3 · Lessons 6–7 — Evaluating and Equivalent Expressions</a:t>
             </a:r>
           </a:p>
         </p:txBody>
@@ -19535,7 +19535,7 @@
                 </a:solidFill>
                 <a:latin typeface="Century Schoolbook"/>
               </a:rPr>
-              <a:t>Grade 7 Accelerated · Unit 3 · Lesson 6–7 — Evaluating and Equivalent Expressions</a:t>
+              <a:t>Grade 7 Accelerated · Unit 3 · Lessons 6–7 — Evaluating and Equivalent Expressions</a:t>
             </a:r>
           </a:p>
         </p:txBody>
@@ -20045,7 +20045,7 @@
                 </a:solidFill>
                 <a:latin typeface="Century Schoolbook"/>
               </a:rPr>
-              <a:t>Grade 7 Accelerated · Unit 3 · Lesson 6–7 — Evaluating and Equivalent Expressions</a:t>
+              <a:t>Grade 7 Accelerated · Unit 3 · Lessons 6–7 — Evaluating and Equivalent Expressions</a:t>
             </a:r>
           </a:p>
         </p:txBody>
@@ -20367,7 +20367,7 @@
                 </a:solidFill>
                 <a:latin typeface="Century Schoolbook"/>
               </a:rPr>
-              <a:t>Grade 7 Accelerated · Unit 3 · Lesson 6–7 — Evaluating and Equivalent Expressions</a:t>
+              <a:t>Grade 7 Accelerated · Unit 3 · Lessons 6–7 — Evaluating and Equivalent Expressions</a:t>
             </a:r>
           </a:p>
         </p:txBody>

</xml_diff>